<commit_message>
renovacion informe y presentacion
</commit_message>
<xml_diff>
--- a/Presentacion.pptx
+++ b/Presentacion.pptx
@@ -8310,20 +8310,20 @@
       </p:sp>
       <p:sp>
         <p:nvSpPr>
-          <p:cNvPr id="6" name="Shape 4"/>
-          <p:cNvSpPr/>
-          <p:nvPr/>
-        </p:nvSpPr>
-        <p:spPr>
-          <a:xfrm>
-            <a:off x="320040" y="1965960"/>
+          <p:cNvPr id="9" name="Shape 6"/>
+          <p:cNvSpPr/>
+          <p:nvPr/>
+        </p:nvSpPr>
+        <p:spPr>
+          <a:xfrm>
+            <a:off x="333756" y="1908810"/>
             <a:ext cx="64008" cy="1325880"/>
           </a:xfrm>
           <a:prstGeom prst="rect">
             <a:avLst/>
           </a:prstGeom>
           <a:solidFill>
-            <a:srgbClr val="2C5F2D"/>
+            <a:srgbClr val="6FCF57"/>
           </a:solidFill>
           <a:ln/>
         </p:spPr>
@@ -8337,14 +8337,14 @@
       </p:sp>
       <p:sp>
         <p:nvSpPr>
-          <p:cNvPr id="7" name="Text 5"/>
-          <p:cNvSpPr/>
-          <p:nvPr/>
-        </p:nvSpPr>
-        <p:spPr>
-          <a:xfrm>
-            <a:off x="502920" y="1965960"/>
-            <a:ext cx="3931920" cy="320040"/>
+          <p:cNvPr id="10" name="Text 7"/>
+          <p:cNvSpPr/>
+          <p:nvPr/>
+        </p:nvSpPr>
+        <p:spPr>
+          <a:xfrm>
+            <a:off x="510540" y="1892617"/>
+            <a:ext cx="4114800" cy="320040"/>
           </a:xfrm>
           <a:prstGeom prst="rect">
             <a:avLst/>
@@ -8368,7 +8368,7 @@
                 <a:ea typeface="Arial" pitchFamily="34" charset="-122"/>
                 <a:cs typeface="Arial" pitchFamily="34" charset="-120"/>
               </a:rPr>
-              <a:t>EfficientNetB0 — Modelo 8</a:t>
+              <a:t>DenseNet121 — Modelo 9</a:t>
             </a:r>
             <a:endParaRPr lang="en-US" sz="1200" dirty="0"/>
           </a:p>
@@ -8376,20 +8376,20 @@
       </p:sp>
       <p:graphicFrame>
         <p:nvGraphicFramePr>
-          <p:cNvPr id="8" name="Table 0"/>
+          <p:cNvPr id="15" name="Table 1"/>
           <p:cNvGraphicFramePr>
             <a:graphicFrameLocks noGrp="1"/>
           </p:cNvGraphicFramePr>
           <p:nvPr>
             <p:extLst>
               <p:ext uri="{D42A27DB-BD31-4B8C-83A1-F6EECF244321}">
-                <p14:modId xmlns:p14="http://schemas.microsoft.com/office/powerpoint/2010/main" val="3424505495"/>
+                <p14:modId xmlns:p14="http://schemas.microsoft.com/office/powerpoint/2010/main" val="4110269920"/>
               </p:ext>
             </p:extLst>
           </p:nvPr>
         </p:nvGraphicFramePr>
         <p:xfrm>
-          <a:off x="320040" y="2331720"/>
+          <a:off x="320040" y="2212657"/>
           <a:ext cx="4114800" cy="2359152"/>
         </p:xfrm>
         <a:graphic>
@@ -8491,7 +8491,7 @@
                       <a:tailEnd type="none" w="med" len="med"/>
                     </a:lnB>
                     <a:solidFill>
-                      <a:srgbClr val="2C5F2D"/>
+                      <a:srgbClr val="1B3A2D"/>
                     </a:solidFill>
                   </a:tcPr>
                 </a:tc>
@@ -8559,7 +8559,7 @@
                       <a:tailEnd type="none" w="med" len="med"/>
                     </a:lnB>
                     <a:solidFill>
-                      <a:srgbClr val="2C5F2D"/>
+                      <a:srgbClr val="1B3A2D"/>
                     </a:solidFill>
                   </a:tcPr>
                 </a:tc>
@@ -8627,7 +8627,7 @@
                       <a:tailEnd type="none" w="med" len="med"/>
                     </a:lnB>
                     <a:solidFill>
-                      <a:srgbClr val="2C5F2D"/>
+                      <a:srgbClr val="1B3A2D"/>
                     </a:solidFill>
                   </a:tcPr>
                 </a:tc>
@@ -8695,7 +8695,7 @@
                       <a:tailEnd type="none" w="med" len="med"/>
                     </a:lnB>
                     <a:solidFill>
-                      <a:srgbClr val="2C5F2D"/>
+                      <a:srgbClr val="1B3A2D"/>
                     </a:solidFill>
                   </a:tcPr>
                 </a:tc>
@@ -8791,7 +8791,7 @@
                           <a:ea typeface="Calibri" pitchFamily="34" charset="-122"/>
                           <a:cs typeface="Calibri" pitchFamily="34" charset="-120"/>
                         </a:rPr>
-                        <a:t>0,9990</a:t>
+                        <a:t>0,9960</a:t>
                       </a:r>
                       <a:endParaRPr lang="en-US" sz="1100" dirty="0">
                         <a:latin typeface="Calibri" charset="0"/>
@@ -8859,7 +8859,7 @@
                           <a:ea typeface="Calibri" pitchFamily="34" charset="-122"/>
                           <a:cs typeface="Calibri" pitchFamily="34" charset="-120"/>
                         </a:rPr>
-                        <a:t>0,9249</a:t>
+                        <a:t>0,9289</a:t>
                       </a:r>
                       <a:endParaRPr lang="en-US" sz="1100" dirty="0">
                         <a:latin typeface="Calibri" charset="0"/>
@@ -8927,7 +8927,7 @@
                           <a:ea typeface="Calibri" pitchFamily="34" charset="-122"/>
                           <a:cs typeface="Calibri" pitchFamily="34" charset="-120"/>
                         </a:rPr>
-                        <a:t>0,9012</a:t>
+                        <a:t>0,9051</a:t>
                       </a:r>
                       <a:endParaRPr lang="en-US" sz="1100" dirty="0">
                         <a:latin typeface="Calibri" charset="0"/>
@@ -9070,7 +9070,7 @@
                           <a:ea typeface="Calibri" pitchFamily="34" charset="-122"/>
                           <a:cs typeface="Calibri" pitchFamily="34" charset="-120"/>
                         </a:rPr>
-                        <a:t>0,9980</a:t>
+                        <a:t>0,9990</a:t>
                       </a:r>
                       <a:endParaRPr lang="en-US" sz="1100" dirty="0">
                         <a:latin typeface="Calibri" charset="0"/>
@@ -9138,7 +9138,7 @@
                           <a:ea typeface="Calibri" pitchFamily="34" charset="-122"/>
                           <a:cs typeface="Calibri" pitchFamily="34" charset="-120"/>
                         </a:rPr>
-                        <a:t>0,9012</a:t>
+                        <a:t>0,9209</a:t>
                       </a:r>
                       <a:endParaRPr lang="en-US" sz="1100" dirty="0">
                         <a:latin typeface="Calibri" charset="0"/>
@@ -9206,7 +9206,7 @@
                           <a:ea typeface="Calibri" pitchFamily="34" charset="-122"/>
                           <a:cs typeface="Calibri" pitchFamily="34" charset="-120"/>
                         </a:rPr>
-                        <a:t>0,8617</a:t>
+                        <a:t>0,8854</a:t>
                       </a:r>
                       <a:endParaRPr lang="en-US" sz="1100" dirty="0">
                         <a:latin typeface="Calibri" charset="0"/>
@@ -9349,7 +9349,7 @@
                           <a:ea typeface="Calibri" pitchFamily="34" charset="-122"/>
                           <a:cs typeface="Calibri" pitchFamily="34" charset="-120"/>
                         </a:rPr>
-                        <a:t>0,9985</a:t>
+                        <a:t>0,9990</a:t>
                       </a:r>
                       <a:endParaRPr lang="en-US" sz="1100" dirty="0">
                         <a:latin typeface="Calibri" charset="0"/>
@@ -9417,7 +9417,7 @@
                           <a:ea typeface="Calibri" pitchFamily="34" charset="-122"/>
                           <a:cs typeface="Calibri" pitchFamily="34" charset="-120"/>
                         </a:rPr>
-                        <a:t>0,9249</a:t>
+                        <a:t>0,8833</a:t>
                       </a:r>
                       <a:endParaRPr lang="en-US" sz="1100" dirty="0">
                         <a:latin typeface="Calibri" charset="0"/>
@@ -9485,7 +9485,7 @@
                           <a:ea typeface="Calibri" pitchFamily="34" charset="-122"/>
                           <a:cs typeface="Calibri" pitchFamily="34" charset="-120"/>
                         </a:rPr>
-                        <a:t>0,8775</a:t>
+                        <a:t>0,8577</a:t>
                       </a:r>
                       <a:endParaRPr lang="en-US" sz="1100" dirty="0">
                         <a:latin typeface="Calibri" charset="0"/>
@@ -9628,7 +9628,7 @@
                           <a:ea typeface="Calibri" pitchFamily="34" charset="-122"/>
                           <a:cs typeface="Calibri" pitchFamily="34" charset="-120"/>
                         </a:rPr>
-                        <a:t>0,9985</a:t>
+                        <a:t>0,9990</a:t>
                       </a:r>
                       <a:endParaRPr lang="en-US" sz="1100" dirty="0">
                         <a:latin typeface="Calibri" charset="0"/>
@@ -9696,7 +9696,7 @@
                           <a:ea typeface="Calibri" pitchFamily="34" charset="-122"/>
                           <a:cs typeface="Calibri" pitchFamily="34" charset="-120"/>
                         </a:rPr>
-                        <a:t>0,8893</a:t>
+                        <a:t>0,8775</a:t>
                       </a:r>
                       <a:endParaRPr lang="en-US" sz="1100" dirty="0">
                         <a:latin typeface="Calibri" charset="0"/>
@@ -9764,1803 +9764,7 @@
                           <a:ea typeface="Calibri" pitchFamily="34" charset="-122"/>
                           <a:cs typeface="Calibri" pitchFamily="34" charset="-120"/>
                         </a:rPr>
-                        <a:t>0,8656</a:t>
-                      </a:r>
-                      <a:endParaRPr lang="en-US" sz="1100" dirty="0">
-                        <a:latin typeface="Calibri" charset="0"/>
-                        <a:ea typeface="Calibri" charset="0"/>
-                        <a:cs typeface="Calibri" charset="0"/>
-                      </a:endParaRPr>
-                    </a:p>
-                  </a:txBody>
-                  <a:tcPr>
-                    <a:lnL w="6350" cap="flat" cmpd="sng" algn="ctr">
-                      <a:solidFill>
-                        <a:srgbClr val="CCDDCC"/>
-                      </a:solidFill>
-                      <a:prstDash val="solid"/>
-                      <a:round/>
-                      <a:headEnd type="none" w="med" len="med"/>
-                      <a:tailEnd type="none" w="med" len="med"/>
-                    </a:lnL>
-                    <a:lnR w="6350" cap="flat" cmpd="sng" algn="ctr">
-                      <a:solidFill>
-                        <a:srgbClr val="CCDDCC"/>
-                      </a:solidFill>
-                      <a:prstDash val="solid"/>
-                      <a:round/>
-                      <a:headEnd type="none" w="med" len="med"/>
-                      <a:tailEnd type="none" w="med" len="med"/>
-                    </a:lnR>
-                    <a:lnT w="6350" cap="flat" cmpd="sng" algn="ctr">
-                      <a:solidFill>
-                        <a:srgbClr val="CCDDCC"/>
-                      </a:solidFill>
-                      <a:prstDash val="solid"/>
-                      <a:round/>
-                      <a:headEnd type="none" w="med" len="med"/>
-                      <a:tailEnd type="none" w="med" len="med"/>
-                    </a:lnT>
-                    <a:lnB w="6350" cap="flat" cmpd="sng" algn="ctr">
-                      <a:solidFill>
-                        <a:srgbClr val="CCDDCC"/>
-                      </a:solidFill>
-                      <a:prstDash val="solid"/>
-                      <a:round/>
-                      <a:headEnd type="none" w="med" len="med"/>
-                      <a:tailEnd type="none" w="med" len="med"/>
-                    </a:lnB>
-                    <a:solidFill>
-                      <a:srgbClr val="FFFFFF"/>
-                    </a:solidFill>
-                  </a:tcPr>
-                </a:tc>
-                <a:extLst>
-                  <a:ext uri="{0D108BD9-81ED-4DB2-BD59-A6C34878D82A}">
-                    <a16:rowId xmlns:a16="http://schemas.microsoft.com/office/drawing/2014/main" val="10004"/>
-                  </a:ext>
-                </a:extLst>
-              </a:tr>
-              <a:tr h="393192">
-                <a:tc>
-                  <a:txBody>
-                    <a:bodyPr/>
-                    <a:lstStyle/>
-                    <a:p>
-                      <a:pPr marL="0" indent="0">
-                        <a:buNone/>
-                      </a:pPr>
-                      <a:r>
-                        <a:rPr lang="en-US" sz="1100" b="1" dirty="0">
-                          <a:solidFill>
-                            <a:srgbClr val="FFFFFF"/>
-                          </a:solidFill>
-                          <a:latin typeface="Calibri" pitchFamily="34" charset="0"/>
-                          <a:ea typeface="Calibri" pitchFamily="34" charset="-122"/>
-                          <a:cs typeface="Calibri" pitchFamily="34" charset="-120"/>
-                        </a:rPr>
-                        <a:t>Media</a:t>
-                      </a:r>
-                      <a:endParaRPr lang="en-US" sz="1100" dirty="0">
-                        <a:latin typeface="Calibri" charset="0"/>
-                        <a:ea typeface="Calibri" charset="0"/>
-                        <a:cs typeface="Calibri" charset="0"/>
-                      </a:endParaRPr>
-                    </a:p>
-                  </a:txBody>
-                  <a:tcPr>
-                    <a:lnL w="6350" cap="flat" cmpd="sng" algn="ctr">
-                      <a:solidFill>
-                        <a:srgbClr val="CCDDCC"/>
-                      </a:solidFill>
-                      <a:prstDash val="solid"/>
-                      <a:round/>
-                      <a:headEnd type="none" w="med" len="med"/>
-                      <a:tailEnd type="none" w="med" len="med"/>
-                    </a:lnL>
-                    <a:lnR w="6350" cap="flat" cmpd="sng" algn="ctr">
-                      <a:solidFill>
-                        <a:srgbClr val="CCDDCC"/>
-                      </a:solidFill>
-                      <a:prstDash val="solid"/>
-                      <a:round/>
-                      <a:headEnd type="none" w="med" len="med"/>
-                      <a:tailEnd type="none" w="med" len="med"/>
-                    </a:lnR>
-                    <a:lnT w="6350" cap="flat" cmpd="sng" algn="ctr">
-                      <a:solidFill>
-                        <a:srgbClr val="CCDDCC"/>
-                      </a:solidFill>
-                      <a:prstDash val="solid"/>
-                      <a:round/>
-                      <a:headEnd type="none" w="med" len="med"/>
-                      <a:tailEnd type="none" w="med" len="med"/>
-                    </a:lnT>
-                    <a:lnB w="6350" cap="flat" cmpd="sng" algn="ctr">
-                      <a:solidFill>
-                        <a:srgbClr val="CCDDCC"/>
-                      </a:solidFill>
-                      <a:prstDash val="solid"/>
-                      <a:round/>
-                      <a:headEnd type="none" w="med" len="med"/>
-                      <a:tailEnd type="none" w="med" len="med"/>
-                    </a:lnB>
-                    <a:solidFill>
-                      <a:srgbClr val="334155"/>
-                    </a:solidFill>
-                  </a:tcPr>
-                </a:tc>
-                <a:tc>
-                  <a:txBody>
-                    <a:bodyPr/>
-                    <a:lstStyle/>
-                    <a:p>
-                      <a:pPr marL="0" indent="0">
-                        <a:buNone/>
-                      </a:pPr>
-                      <a:r>
-                        <a:rPr lang="en-US" sz="1100" b="1" dirty="0">
-                          <a:solidFill>
-                            <a:srgbClr val="FFFFFF"/>
-                          </a:solidFill>
-                          <a:latin typeface="Calibri" pitchFamily="34" charset="0"/>
-                          <a:ea typeface="Calibri" pitchFamily="34" charset="-122"/>
-                          <a:cs typeface="Calibri" pitchFamily="34" charset="-120"/>
-                        </a:rPr>
-                        <a:t>0,9985</a:t>
-                      </a:r>
-                      <a:endParaRPr lang="en-US" sz="1100" dirty="0">
-                        <a:latin typeface="Calibri" charset="0"/>
-                        <a:ea typeface="Calibri" charset="0"/>
-                        <a:cs typeface="Calibri" charset="0"/>
-                      </a:endParaRPr>
-                    </a:p>
-                  </a:txBody>
-                  <a:tcPr>
-                    <a:lnL w="6350" cap="flat" cmpd="sng" algn="ctr">
-                      <a:solidFill>
-                        <a:srgbClr val="CCDDCC"/>
-                      </a:solidFill>
-                      <a:prstDash val="solid"/>
-                      <a:round/>
-                      <a:headEnd type="none" w="med" len="med"/>
-                      <a:tailEnd type="none" w="med" len="med"/>
-                    </a:lnL>
-                    <a:lnR w="6350" cap="flat" cmpd="sng" algn="ctr">
-                      <a:solidFill>
-                        <a:srgbClr val="CCDDCC"/>
-                      </a:solidFill>
-                      <a:prstDash val="solid"/>
-                      <a:round/>
-                      <a:headEnd type="none" w="med" len="med"/>
-                      <a:tailEnd type="none" w="med" len="med"/>
-                    </a:lnR>
-                    <a:lnT w="6350" cap="flat" cmpd="sng" algn="ctr">
-                      <a:solidFill>
-                        <a:srgbClr val="CCDDCC"/>
-                      </a:solidFill>
-                      <a:prstDash val="solid"/>
-                      <a:round/>
-                      <a:headEnd type="none" w="med" len="med"/>
-                      <a:tailEnd type="none" w="med" len="med"/>
-                    </a:lnT>
-                    <a:lnB w="6350" cap="flat" cmpd="sng" algn="ctr">
-                      <a:solidFill>
-                        <a:srgbClr val="CCDDCC"/>
-                      </a:solidFill>
-                      <a:prstDash val="solid"/>
-                      <a:round/>
-                      <a:headEnd type="none" w="med" len="med"/>
-                      <a:tailEnd type="none" w="med" len="med"/>
-                    </a:lnB>
-                    <a:solidFill>
-                      <a:srgbClr val="334155"/>
-                    </a:solidFill>
-                  </a:tcPr>
-                </a:tc>
-                <a:tc>
-                  <a:txBody>
-                    <a:bodyPr/>
-                    <a:lstStyle/>
-                    <a:p>
-                      <a:pPr marL="0" indent="0">
-                        <a:buNone/>
-                      </a:pPr>
-                      <a:r>
-                        <a:rPr lang="en-US" sz="1100" b="1" dirty="0">
-                          <a:solidFill>
-                            <a:srgbClr val="FFFFFF"/>
-                          </a:solidFill>
-                          <a:latin typeface="Calibri" pitchFamily="34" charset="0"/>
-                          <a:ea typeface="Calibri" pitchFamily="34" charset="-122"/>
-                          <a:cs typeface="Calibri" pitchFamily="34" charset="-120"/>
-                        </a:rPr>
-                        <a:t>0,9101</a:t>
-                      </a:r>
-                      <a:endParaRPr lang="en-US" sz="1100" dirty="0">
-                        <a:latin typeface="Calibri" charset="0"/>
-                        <a:ea typeface="Calibri" charset="0"/>
-                        <a:cs typeface="Calibri" charset="0"/>
-                      </a:endParaRPr>
-                    </a:p>
-                  </a:txBody>
-                  <a:tcPr>
-                    <a:lnL w="6350" cap="flat" cmpd="sng" algn="ctr">
-                      <a:solidFill>
-                        <a:srgbClr val="CCDDCC"/>
-                      </a:solidFill>
-                      <a:prstDash val="solid"/>
-                      <a:round/>
-                      <a:headEnd type="none" w="med" len="med"/>
-                      <a:tailEnd type="none" w="med" len="med"/>
-                    </a:lnL>
-                    <a:lnR w="6350" cap="flat" cmpd="sng" algn="ctr">
-                      <a:solidFill>
-                        <a:srgbClr val="CCDDCC"/>
-                      </a:solidFill>
-                      <a:prstDash val="solid"/>
-                      <a:round/>
-                      <a:headEnd type="none" w="med" len="med"/>
-                      <a:tailEnd type="none" w="med" len="med"/>
-                    </a:lnR>
-                    <a:lnT w="6350" cap="flat" cmpd="sng" algn="ctr">
-                      <a:solidFill>
-                        <a:srgbClr val="CCDDCC"/>
-                      </a:solidFill>
-                      <a:prstDash val="solid"/>
-                      <a:round/>
-                      <a:headEnd type="none" w="med" len="med"/>
-                      <a:tailEnd type="none" w="med" len="med"/>
-                    </a:lnT>
-                    <a:lnB w="6350" cap="flat" cmpd="sng" algn="ctr">
-                      <a:solidFill>
-                        <a:srgbClr val="CCDDCC"/>
-                      </a:solidFill>
-                      <a:prstDash val="solid"/>
-                      <a:round/>
-                      <a:headEnd type="none" w="med" len="med"/>
-                      <a:tailEnd type="none" w="med" len="med"/>
-                    </a:lnB>
-                    <a:solidFill>
-                      <a:srgbClr val="334155"/>
-                    </a:solidFill>
-                  </a:tcPr>
-                </a:tc>
-                <a:tc>
-                  <a:txBody>
-                    <a:bodyPr/>
-                    <a:lstStyle/>
-                    <a:p>
-                      <a:pPr marL="0" indent="0">
-                        <a:buNone/>
-                      </a:pPr>
-                      <a:r>
-                        <a:rPr lang="en-US" sz="1100" b="1" dirty="0">
-                          <a:solidFill>
-                            <a:srgbClr val="FFFFFF"/>
-                          </a:solidFill>
-                          <a:latin typeface="Calibri" pitchFamily="34" charset="0"/>
-                          <a:ea typeface="Calibri" pitchFamily="34" charset="-122"/>
-                          <a:cs typeface="Calibri" pitchFamily="34" charset="-120"/>
-                        </a:rPr>
-                        <a:t>0,8765</a:t>
-                      </a:r>
-                      <a:endParaRPr lang="en-US" sz="1100" dirty="0">
-                        <a:latin typeface="Calibri" charset="0"/>
-                        <a:ea typeface="Calibri" charset="0"/>
-                        <a:cs typeface="Calibri" charset="0"/>
-                      </a:endParaRPr>
-                    </a:p>
-                  </a:txBody>
-                  <a:tcPr>
-                    <a:lnL w="6350" cap="flat" cmpd="sng" algn="ctr">
-                      <a:solidFill>
-                        <a:srgbClr val="CCDDCC"/>
-                      </a:solidFill>
-                      <a:prstDash val="solid"/>
-                      <a:round/>
-                      <a:headEnd type="none" w="med" len="med"/>
-                      <a:tailEnd type="none" w="med" len="med"/>
-                    </a:lnL>
-                    <a:lnR w="6350" cap="flat" cmpd="sng" algn="ctr">
-                      <a:solidFill>
-                        <a:srgbClr val="CCDDCC"/>
-                      </a:solidFill>
-                      <a:prstDash val="solid"/>
-                      <a:round/>
-                      <a:headEnd type="none" w="med" len="med"/>
-                      <a:tailEnd type="none" w="med" len="med"/>
-                    </a:lnR>
-                    <a:lnT w="6350" cap="flat" cmpd="sng" algn="ctr">
-                      <a:solidFill>
-                        <a:srgbClr val="CCDDCC"/>
-                      </a:solidFill>
-                      <a:prstDash val="solid"/>
-                      <a:round/>
-                      <a:headEnd type="none" w="med" len="med"/>
-                      <a:tailEnd type="none" w="med" len="med"/>
-                    </a:lnT>
-                    <a:lnB w="6350" cap="flat" cmpd="sng" algn="ctr">
-                      <a:solidFill>
-                        <a:srgbClr val="CCDDCC"/>
-                      </a:solidFill>
-                      <a:prstDash val="solid"/>
-                      <a:round/>
-                      <a:headEnd type="none" w="med" len="med"/>
-                      <a:tailEnd type="none" w="med" len="med"/>
-                    </a:lnB>
-                    <a:solidFill>
-                      <a:srgbClr val="334155"/>
-                    </a:solidFill>
-                  </a:tcPr>
-                </a:tc>
-                <a:extLst>
-                  <a:ext uri="{0D108BD9-81ED-4DB2-BD59-A6C34878D82A}">
-                    <a16:rowId xmlns:a16="http://schemas.microsoft.com/office/drawing/2014/main" val="10005"/>
-                  </a:ext>
-                </a:extLst>
-              </a:tr>
-            </a:tbl>
-          </a:graphicData>
-        </a:graphic>
-      </p:graphicFrame>
-      <p:sp>
-        <p:nvSpPr>
-          <p:cNvPr id="9" name="Shape 6"/>
-          <p:cNvSpPr/>
-          <p:nvPr/>
-        </p:nvSpPr>
-        <p:spPr>
-          <a:xfrm>
-            <a:off x="4709160" y="1965960"/>
-            <a:ext cx="64008" cy="1325880"/>
-          </a:xfrm>
-          <a:prstGeom prst="rect">
-            <a:avLst/>
-          </a:prstGeom>
-          <a:solidFill>
-            <a:srgbClr val="6FCF57"/>
-          </a:solidFill>
-          <a:ln/>
-        </p:spPr>
-        <p:txBody>
-          <a:bodyPr/>
-          <a:lstStyle/>
-          <a:p>
-            <a:endParaRPr lang="es-ES"/>
-          </a:p>
-        </p:txBody>
-      </p:sp>
-      <p:sp>
-        <p:nvSpPr>
-          <p:cNvPr id="10" name="Text 7"/>
-          <p:cNvSpPr/>
-          <p:nvPr/>
-        </p:nvSpPr>
-        <p:spPr>
-          <a:xfrm>
-            <a:off x="4892040" y="1965960"/>
-            <a:ext cx="4114800" cy="320040"/>
-          </a:xfrm>
-          <a:prstGeom prst="rect">
-            <a:avLst/>
-          </a:prstGeom>
-          <a:noFill/>
-          <a:ln/>
-        </p:spPr>
-        <p:txBody>
-          <a:bodyPr wrap="square" lIns="0" tIns="0" rIns="0" bIns="0" rtlCol="0" anchor="ctr"/>
-          <a:lstStyle/>
-          <a:p>
-            <a:pPr marL="0" indent="0" algn="l">
-              <a:buNone/>
-            </a:pPr>
-            <a:r>
-              <a:rPr lang="en-US" sz="1200" b="1" dirty="0">
-                <a:solidFill>
-                  <a:srgbClr val="1B3A2D"/>
-                </a:solidFill>
-                <a:latin typeface="Arial" pitchFamily="34" charset="0"/>
-                <a:ea typeface="Arial" pitchFamily="34" charset="-122"/>
-                <a:cs typeface="Arial" pitchFamily="34" charset="-120"/>
-              </a:rPr>
-              <a:t>DenseNet121 — Modelo 9</a:t>
-            </a:r>
-            <a:endParaRPr lang="en-US" sz="1200" dirty="0"/>
-          </a:p>
-        </p:txBody>
-      </p:sp>
-      <p:graphicFrame>
-        <p:nvGraphicFramePr>
-          <p:cNvPr id="15" name="Table 1"/>
-          <p:cNvGraphicFramePr>
-            <a:graphicFrameLocks noGrp="1"/>
-          </p:cNvGraphicFramePr>
-          <p:nvPr>
-            <p:extLst>
-              <p:ext uri="{D42A27DB-BD31-4B8C-83A1-F6EECF244321}">
-                <p14:modId xmlns:p14="http://schemas.microsoft.com/office/powerpoint/2010/main" val="2808394842"/>
-              </p:ext>
-            </p:extLst>
-          </p:nvPr>
-        </p:nvGraphicFramePr>
-        <p:xfrm>
-          <a:off x="4709160" y="2331720"/>
-          <a:ext cx="4114800" cy="2359152"/>
-        </p:xfrm>
-        <a:graphic>
-          <a:graphicData uri="http://schemas.openxmlformats.org/drawingml/2006/table">
-            <a:tbl>
-              <a:tblPr/>
-              <a:tblGrid>
-                <a:gridCol w="914400">
-                  <a:extLst>
-                    <a:ext uri="{9D8B030D-6E8A-4147-A177-3AD203B41FA5}">
-                      <a16:colId xmlns:a16="http://schemas.microsoft.com/office/drawing/2014/main" val="20000"/>
-                    </a:ext>
-                  </a:extLst>
-                </a:gridCol>
-                <a:gridCol w="1069848">
-                  <a:extLst>
-                    <a:ext uri="{9D8B030D-6E8A-4147-A177-3AD203B41FA5}">
-                      <a16:colId xmlns:a16="http://schemas.microsoft.com/office/drawing/2014/main" val="20001"/>
-                    </a:ext>
-                  </a:extLst>
-                </a:gridCol>
-                <a:gridCol w="1069848">
-                  <a:extLst>
-                    <a:ext uri="{9D8B030D-6E8A-4147-A177-3AD203B41FA5}">
-                      <a16:colId xmlns:a16="http://schemas.microsoft.com/office/drawing/2014/main" val="20002"/>
-                    </a:ext>
-                  </a:extLst>
-                </a:gridCol>
-                <a:gridCol w="1060704">
-                  <a:extLst>
-                    <a:ext uri="{9D8B030D-6E8A-4147-A177-3AD203B41FA5}">
-                      <a16:colId xmlns:a16="http://schemas.microsoft.com/office/drawing/2014/main" val="20003"/>
-                    </a:ext>
-                  </a:extLst>
-                </a:gridCol>
-              </a:tblGrid>
-              <a:tr h="393192">
-                <a:tc>
-                  <a:txBody>
-                    <a:bodyPr/>
-                    <a:lstStyle/>
-                    <a:p>
-                      <a:pPr marL="0" indent="0">
-                        <a:buNone/>
-                      </a:pPr>
-                      <a:r>
-                        <a:rPr lang="en-US" sz="1100" b="1" dirty="0">
-                          <a:solidFill>
-                            <a:srgbClr val="FFFFFF"/>
-                          </a:solidFill>
-                          <a:latin typeface="Calibri" pitchFamily="34" charset="0"/>
-                          <a:ea typeface="Calibri" pitchFamily="34" charset="-122"/>
-                          <a:cs typeface="Calibri" pitchFamily="34" charset="-120"/>
-                        </a:rPr>
-                        <a:t>Semilla</a:t>
-                      </a:r>
-                      <a:endParaRPr lang="en-US" sz="1100" dirty="0">
-                        <a:latin typeface="Calibri" charset="0"/>
-                        <a:ea typeface="Calibri" charset="0"/>
-                        <a:cs typeface="Calibri" charset="0"/>
-                      </a:endParaRPr>
-                    </a:p>
-                  </a:txBody>
-                  <a:tcPr>
-                    <a:lnL w="6350" cap="flat" cmpd="sng" algn="ctr">
-                      <a:solidFill>
-                        <a:srgbClr val="CCDDCC"/>
-                      </a:solidFill>
-                      <a:prstDash val="solid"/>
-                      <a:round/>
-                      <a:headEnd type="none" w="med" len="med"/>
-                      <a:tailEnd type="none" w="med" len="med"/>
-                    </a:lnL>
-                    <a:lnR w="6350" cap="flat" cmpd="sng" algn="ctr">
-                      <a:solidFill>
-                        <a:srgbClr val="CCDDCC"/>
-                      </a:solidFill>
-                      <a:prstDash val="solid"/>
-                      <a:round/>
-                      <a:headEnd type="none" w="med" len="med"/>
-                      <a:tailEnd type="none" w="med" len="med"/>
-                    </a:lnR>
-                    <a:lnT w="6350" cap="flat" cmpd="sng" algn="ctr">
-                      <a:solidFill>
-                        <a:srgbClr val="CCDDCC"/>
-                      </a:solidFill>
-                      <a:prstDash val="solid"/>
-                      <a:round/>
-                      <a:headEnd type="none" w="med" len="med"/>
-                      <a:tailEnd type="none" w="med" len="med"/>
-                    </a:lnT>
-                    <a:lnB w="6350" cap="flat" cmpd="sng" algn="ctr">
-                      <a:solidFill>
-                        <a:srgbClr val="CCDDCC"/>
-                      </a:solidFill>
-                      <a:prstDash val="solid"/>
-                      <a:round/>
-                      <a:headEnd type="none" w="med" len="med"/>
-                      <a:tailEnd type="none" w="med" len="med"/>
-                    </a:lnB>
-                    <a:solidFill>
-                      <a:srgbClr val="1B3A2D"/>
-                    </a:solidFill>
-                  </a:tcPr>
-                </a:tc>
-                <a:tc>
-                  <a:txBody>
-                    <a:bodyPr/>
-                    <a:lstStyle/>
-                    <a:p>
-                      <a:pPr marL="0" indent="0">
-                        <a:buNone/>
-                      </a:pPr>
-                      <a:r>
-                        <a:rPr lang="en-US" sz="1100" b="1" dirty="0">
-                          <a:solidFill>
-                            <a:srgbClr val="FFFFFF"/>
-                          </a:solidFill>
-                          <a:latin typeface="Calibri" pitchFamily="34" charset="0"/>
-                          <a:ea typeface="Calibri" pitchFamily="34" charset="-122"/>
-                          <a:cs typeface="Calibri" pitchFamily="34" charset="-120"/>
-                        </a:rPr>
-                        <a:t>Train</a:t>
-                      </a:r>
-                      <a:endParaRPr lang="en-US" sz="1100" dirty="0">
-                        <a:latin typeface="Calibri" charset="0"/>
-                        <a:ea typeface="Calibri" charset="0"/>
-                        <a:cs typeface="Calibri" charset="0"/>
-                      </a:endParaRPr>
-                    </a:p>
-                  </a:txBody>
-                  <a:tcPr>
-                    <a:lnL w="6350" cap="flat" cmpd="sng" algn="ctr">
-                      <a:solidFill>
-                        <a:srgbClr val="CCDDCC"/>
-                      </a:solidFill>
-                      <a:prstDash val="solid"/>
-                      <a:round/>
-                      <a:headEnd type="none" w="med" len="med"/>
-                      <a:tailEnd type="none" w="med" len="med"/>
-                    </a:lnL>
-                    <a:lnR w="6350" cap="flat" cmpd="sng" algn="ctr">
-                      <a:solidFill>
-                        <a:srgbClr val="CCDDCC"/>
-                      </a:solidFill>
-                      <a:prstDash val="solid"/>
-                      <a:round/>
-                      <a:headEnd type="none" w="med" len="med"/>
-                      <a:tailEnd type="none" w="med" len="med"/>
-                    </a:lnR>
-                    <a:lnT w="6350" cap="flat" cmpd="sng" algn="ctr">
-                      <a:solidFill>
-                        <a:srgbClr val="CCDDCC"/>
-                      </a:solidFill>
-                      <a:prstDash val="solid"/>
-                      <a:round/>
-                      <a:headEnd type="none" w="med" len="med"/>
-                      <a:tailEnd type="none" w="med" len="med"/>
-                    </a:lnT>
-                    <a:lnB w="6350" cap="flat" cmpd="sng" algn="ctr">
-                      <a:solidFill>
-                        <a:srgbClr val="CCDDCC"/>
-                      </a:solidFill>
-                      <a:prstDash val="solid"/>
-                      <a:round/>
-                      <a:headEnd type="none" w="med" len="med"/>
-                      <a:tailEnd type="none" w="med" len="med"/>
-                    </a:lnB>
-                    <a:solidFill>
-                      <a:srgbClr val="1B3A2D"/>
-                    </a:solidFill>
-                  </a:tcPr>
-                </a:tc>
-                <a:tc>
-                  <a:txBody>
-                    <a:bodyPr/>
-                    <a:lstStyle/>
-                    <a:p>
-                      <a:pPr marL="0" indent="0">
-                        <a:buNone/>
-                      </a:pPr>
-                      <a:r>
-                        <a:rPr lang="en-US" sz="1100" b="1" dirty="0">
-                          <a:solidFill>
-                            <a:srgbClr val="FFFFFF"/>
-                          </a:solidFill>
-                          <a:latin typeface="Calibri" pitchFamily="34" charset="0"/>
-                          <a:ea typeface="Calibri" pitchFamily="34" charset="-122"/>
-                          <a:cs typeface="Calibri" pitchFamily="34" charset="-120"/>
-                        </a:rPr>
-                        <a:t>Val</a:t>
-                      </a:r>
-                      <a:endParaRPr lang="en-US" sz="1100" dirty="0">
-                        <a:latin typeface="Calibri" charset="0"/>
-                        <a:ea typeface="Calibri" charset="0"/>
-                        <a:cs typeface="Calibri" charset="0"/>
-                      </a:endParaRPr>
-                    </a:p>
-                  </a:txBody>
-                  <a:tcPr>
-                    <a:lnL w="6350" cap="flat" cmpd="sng" algn="ctr">
-                      <a:solidFill>
-                        <a:srgbClr val="CCDDCC"/>
-                      </a:solidFill>
-                      <a:prstDash val="solid"/>
-                      <a:round/>
-                      <a:headEnd type="none" w="med" len="med"/>
-                      <a:tailEnd type="none" w="med" len="med"/>
-                    </a:lnL>
-                    <a:lnR w="6350" cap="flat" cmpd="sng" algn="ctr">
-                      <a:solidFill>
-                        <a:srgbClr val="CCDDCC"/>
-                      </a:solidFill>
-                      <a:prstDash val="solid"/>
-                      <a:round/>
-                      <a:headEnd type="none" w="med" len="med"/>
-                      <a:tailEnd type="none" w="med" len="med"/>
-                    </a:lnR>
-                    <a:lnT w="6350" cap="flat" cmpd="sng" algn="ctr">
-                      <a:solidFill>
-                        <a:srgbClr val="CCDDCC"/>
-                      </a:solidFill>
-                      <a:prstDash val="solid"/>
-                      <a:round/>
-                      <a:headEnd type="none" w="med" len="med"/>
-                      <a:tailEnd type="none" w="med" len="med"/>
-                    </a:lnT>
-                    <a:lnB w="6350" cap="flat" cmpd="sng" algn="ctr">
-                      <a:solidFill>
-                        <a:srgbClr val="CCDDCC"/>
-                      </a:solidFill>
-                      <a:prstDash val="solid"/>
-                      <a:round/>
-                      <a:headEnd type="none" w="med" len="med"/>
-                      <a:tailEnd type="none" w="med" len="med"/>
-                    </a:lnB>
-                    <a:solidFill>
-                      <a:srgbClr val="1B3A2D"/>
-                    </a:solidFill>
-                  </a:tcPr>
-                </a:tc>
-                <a:tc>
-                  <a:txBody>
-                    <a:bodyPr/>
-                    <a:lstStyle/>
-                    <a:p>
-                      <a:pPr marL="0" indent="0">
-                        <a:buNone/>
-                      </a:pPr>
-                      <a:r>
-                        <a:rPr lang="en-US" sz="1100" b="1" dirty="0">
-                          <a:solidFill>
-                            <a:srgbClr val="FFFFFF"/>
-                          </a:solidFill>
-                          <a:latin typeface="Calibri" pitchFamily="34" charset="0"/>
-                          <a:ea typeface="Calibri" pitchFamily="34" charset="-122"/>
-                          <a:cs typeface="Calibri" pitchFamily="34" charset="-120"/>
-                        </a:rPr>
-                        <a:t>Test</a:t>
-                      </a:r>
-                      <a:endParaRPr lang="en-US" sz="1100" dirty="0">
-                        <a:latin typeface="Calibri" charset="0"/>
-                        <a:ea typeface="Calibri" charset="0"/>
-                        <a:cs typeface="Calibri" charset="0"/>
-                      </a:endParaRPr>
-                    </a:p>
-                  </a:txBody>
-                  <a:tcPr>
-                    <a:lnL w="6350" cap="flat" cmpd="sng" algn="ctr">
-                      <a:solidFill>
-                        <a:srgbClr val="CCDDCC"/>
-                      </a:solidFill>
-                      <a:prstDash val="solid"/>
-                      <a:round/>
-                      <a:headEnd type="none" w="med" len="med"/>
-                      <a:tailEnd type="none" w="med" len="med"/>
-                    </a:lnL>
-                    <a:lnR w="6350" cap="flat" cmpd="sng" algn="ctr">
-                      <a:solidFill>
-                        <a:srgbClr val="CCDDCC"/>
-                      </a:solidFill>
-                      <a:prstDash val="solid"/>
-                      <a:round/>
-                      <a:headEnd type="none" w="med" len="med"/>
-                      <a:tailEnd type="none" w="med" len="med"/>
-                    </a:lnR>
-                    <a:lnT w="6350" cap="flat" cmpd="sng" algn="ctr">
-                      <a:solidFill>
-                        <a:srgbClr val="CCDDCC"/>
-                      </a:solidFill>
-                      <a:prstDash val="solid"/>
-                      <a:round/>
-                      <a:headEnd type="none" w="med" len="med"/>
-                      <a:tailEnd type="none" w="med" len="med"/>
-                    </a:lnT>
-                    <a:lnB w="6350" cap="flat" cmpd="sng" algn="ctr">
-                      <a:solidFill>
-                        <a:srgbClr val="CCDDCC"/>
-                      </a:solidFill>
-                      <a:prstDash val="solid"/>
-                      <a:round/>
-                      <a:headEnd type="none" w="med" len="med"/>
-                      <a:tailEnd type="none" w="med" len="med"/>
-                    </a:lnB>
-                    <a:solidFill>
-                      <a:srgbClr val="1B3A2D"/>
-                    </a:solidFill>
-                  </a:tcPr>
-                </a:tc>
-                <a:extLst>
-                  <a:ext uri="{0D108BD9-81ED-4DB2-BD59-A6C34878D82A}">
-                    <a16:rowId xmlns:a16="http://schemas.microsoft.com/office/drawing/2014/main" val="10000"/>
-                  </a:ext>
-                </a:extLst>
-              </a:tr>
-              <a:tr h="393192">
-                <a:tc>
-                  <a:txBody>
-                    <a:bodyPr/>
-                    <a:lstStyle/>
-                    <a:p>
-                      <a:pPr marL="0" indent="0">
-                        <a:buNone/>
-                      </a:pPr>
-                      <a:r>
-                        <a:rPr lang="en-US" sz="1100" dirty="0">
-                          <a:solidFill>
-                            <a:srgbClr val="334155"/>
-                          </a:solidFill>
-                          <a:latin typeface="Calibri" pitchFamily="34" charset="0"/>
-                          <a:ea typeface="Calibri" pitchFamily="34" charset="-122"/>
-                          <a:cs typeface="Calibri" pitchFamily="34" charset="-120"/>
-                        </a:rPr>
-                        <a:t>42</a:t>
-                      </a:r>
-                      <a:endParaRPr lang="en-US" sz="1100" dirty="0">
-                        <a:latin typeface="Calibri" charset="0"/>
-                        <a:ea typeface="Calibri" charset="0"/>
-                        <a:cs typeface="Calibri" charset="0"/>
-                      </a:endParaRPr>
-                    </a:p>
-                  </a:txBody>
-                  <a:tcPr>
-                    <a:lnL w="6350" cap="flat" cmpd="sng" algn="ctr">
-                      <a:solidFill>
-                        <a:srgbClr val="CCDDCC"/>
-                      </a:solidFill>
-                      <a:prstDash val="solid"/>
-                      <a:round/>
-                      <a:headEnd type="none" w="med" len="med"/>
-                      <a:tailEnd type="none" w="med" len="med"/>
-                    </a:lnL>
-                    <a:lnR w="6350" cap="flat" cmpd="sng" algn="ctr">
-                      <a:solidFill>
-                        <a:srgbClr val="CCDDCC"/>
-                      </a:solidFill>
-                      <a:prstDash val="solid"/>
-                      <a:round/>
-                      <a:headEnd type="none" w="med" len="med"/>
-                      <a:tailEnd type="none" w="med" len="med"/>
-                    </a:lnR>
-                    <a:lnT w="6350" cap="flat" cmpd="sng" algn="ctr">
-                      <a:solidFill>
-                        <a:srgbClr val="CCDDCC"/>
-                      </a:solidFill>
-                      <a:prstDash val="solid"/>
-                      <a:round/>
-                      <a:headEnd type="none" w="med" len="med"/>
-                      <a:tailEnd type="none" w="med" len="med"/>
-                    </a:lnT>
-                    <a:lnB w="6350" cap="flat" cmpd="sng" algn="ctr">
-                      <a:solidFill>
-                        <a:srgbClr val="CCDDCC"/>
-                      </a:solidFill>
-                      <a:prstDash val="solid"/>
-                      <a:round/>
-                      <a:headEnd type="none" w="med" len="med"/>
-                      <a:tailEnd type="none" w="med" len="med"/>
-                    </a:lnB>
-                    <a:solidFill>
-                      <a:srgbClr val="FFFFFF"/>
-                    </a:solidFill>
-                  </a:tcPr>
-                </a:tc>
-                <a:tc>
-                  <a:txBody>
-                    <a:bodyPr/>
-                    <a:lstStyle/>
-                    <a:p>
-                      <a:pPr marL="0" indent="0">
-                        <a:buNone/>
-                      </a:pPr>
-                      <a:r>
-                        <a:rPr lang="en-US" sz="1100" dirty="0">
-                          <a:solidFill>
-                            <a:srgbClr val="334155"/>
-                          </a:solidFill>
-                          <a:latin typeface="Calibri" pitchFamily="34" charset="0"/>
-                          <a:ea typeface="Calibri" pitchFamily="34" charset="-122"/>
-                          <a:cs typeface="Calibri" pitchFamily="34" charset="-120"/>
-                        </a:rPr>
-                        <a:t>0,9990</a:t>
-                      </a:r>
-                      <a:endParaRPr lang="en-US" sz="1100" dirty="0">
-                        <a:latin typeface="Calibri" charset="0"/>
-                        <a:ea typeface="Calibri" charset="0"/>
-                        <a:cs typeface="Calibri" charset="0"/>
-                      </a:endParaRPr>
-                    </a:p>
-                  </a:txBody>
-                  <a:tcPr>
-                    <a:lnL w="6350" cap="flat" cmpd="sng" algn="ctr">
-                      <a:solidFill>
-                        <a:srgbClr val="CCDDCC"/>
-                      </a:solidFill>
-                      <a:prstDash val="solid"/>
-                      <a:round/>
-                      <a:headEnd type="none" w="med" len="med"/>
-                      <a:tailEnd type="none" w="med" len="med"/>
-                    </a:lnL>
-                    <a:lnR w="6350" cap="flat" cmpd="sng" algn="ctr">
-                      <a:solidFill>
-                        <a:srgbClr val="CCDDCC"/>
-                      </a:solidFill>
-                      <a:prstDash val="solid"/>
-                      <a:round/>
-                      <a:headEnd type="none" w="med" len="med"/>
-                      <a:tailEnd type="none" w="med" len="med"/>
-                    </a:lnR>
-                    <a:lnT w="6350" cap="flat" cmpd="sng" algn="ctr">
-                      <a:solidFill>
-                        <a:srgbClr val="CCDDCC"/>
-                      </a:solidFill>
-                      <a:prstDash val="solid"/>
-                      <a:round/>
-                      <a:headEnd type="none" w="med" len="med"/>
-                      <a:tailEnd type="none" w="med" len="med"/>
-                    </a:lnT>
-                    <a:lnB w="6350" cap="flat" cmpd="sng" algn="ctr">
-                      <a:solidFill>
-                        <a:srgbClr val="CCDDCC"/>
-                      </a:solidFill>
-                      <a:prstDash val="solid"/>
-                      <a:round/>
-                      <a:headEnd type="none" w="med" len="med"/>
-                      <a:tailEnd type="none" w="med" len="med"/>
-                    </a:lnB>
-                    <a:solidFill>
-                      <a:srgbClr val="FFFFFF"/>
-                    </a:solidFill>
-                  </a:tcPr>
-                </a:tc>
-                <a:tc>
-                  <a:txBody>
-                    <a:bodyPr/>
-                    <a:lstStyle/>
-                    <a:p>
-                      <a:pPr marL="0" indent="0">
-                        <a:buNone/>
-                      </a:pPr>
-                      <a:r>
-                        <a:rPr lang="en-US" sz="1100" dirty="0">
-                          <a:solidFill>
-                            <a:srgbClr val="334155"/>
-                          </a:solidFill>
-                          <a:latin typeface="Calibri" pitchFamily="34" charset="0"/>
-                          <a:ea typeface="Calibri" pitchFamily="34" charset="-122"/>
-                          <a:cs typeface="Calibri" pitchFamily="34" charset="-120"/>
-                        </a:rPr>
-                        <a:t>0,8972</a:t>
-                      </a:r>
-                      <a:endParaRPr lang="en-US" sz="1100" dirty="0">
-                        <a:latin typeface="Calibri" charset="0"/>
-                        <a:ea typeface="Calibri" charset="0"/>
-                        <a:cs typeface="Calibri" charset="0"/>
-                      </a:endParaRPr>
-                    </a:p>
-                  </a:txBody>
-                  <a:tcPr>
-                    <a:lnL w="6350" cap="flat" cmpd="sng" algn="ctr">
-                      <a:solidFill>
-                        <a:srgbClr val="CCDDCC"/>
-                      </a:solidFill>
-                      <a:prstDash val="solid"/>
-                      <a:round/>
-                      <a:headEnd type="none" w="med" len="med"/>
-                      <a:tailEnd type="none" w="med" len="med"/>
-                    </a:lnL>
-                    <a:lnR w="6350" cap="flat" cmpd="sng" algn="ctr">
-                      <a:solidFill>
-                        <a:srgbClr val="CCDDCC"/>
-                      </a:solidFill>
-                      <a:prstDash val="solid"/>
-                      <a:round/>
-                      <a:headEnd type="none" w="med" len="med"/>
-                      <a:tailEnd type="none" w="med" len="med"/>
-                    </a:lnR>
-                    <a:lnT w="6350" cap="flat" cmpd="sng" algn="ctr">
-                      <a:solidFill>
-                        <a:srgbClr val="CCDDCC"/>
-                      </a:solidFill>
-                      <a:prstDash val="solid"/>
-                      <a:round/>
-                      <a:headEnd type="none" w="med" len="med"/>
-                      <a:tailEnd type="none" w="med" len="med"/>
-                    </a:lnT>
-                    <a:lnB w="6350" cap="flat" cmpd="sng" algn="ctr">
-                      <a:solidFill>
-                        <a:srgbClr val="CCDDCC"/>
-                      </a:solidFill>
-                      <a:prstDash val="solid"/>
-                      <a:round/>
-                      <a:headEnd type="none" w="med" len="med"/>
-                      <a:tailEnd type="none" w="med" len="med"/>
-                    </a:lnB>
-                    <a:solidFill>
-                      <a:srgbClr val="FFFFFF"/>
-                    </a:solidFill>
-                  </a:tcPr>
-                </a:tc>
-                <a:tc>
-                  <a:txBody>
-                    <a:bodyPr/>
-                    <a:lstStyle/>
-                    <a:p>
-                      <a:pPr marL="0" indent="0">
-                        <a:buNone/>
-                      </a:pPr>
-                      <a:r>
-                        <a:rPr lang="en-US" sz="1100" dirty="0">
-                          <a:solidFill>
-                            <a:srgbClr val="334155"/>
-                          </a:solidFill>
-                          <a:latin typeface="Calibri" pitchFamily="34" charset="0"/>
-                          <a:ea typeface="Calibri" pitchFamily="34" charset="-122"/>
-                          <a:cs typeface="Calibri" pitchFamily="34" charset="-120"/>
-                        </a:rPr>
-                        <a:t>0,9012</a:t>
-                      </a:r>
-                      <a:endParaRPr lang="en-US" sz="1100" dirty="0">
-                        <a:latin typeface="Calibri" charset="0"/>
-                        <a:ea typeface="Calibri" charset="0"/>
-                        <a:cs typeface="Calibri" charset="0"/>
-                      </a:endParaRPr>
-                    </a:p>
-                  </a:txBody>
-                  <a:tcPr>
-                    <a:lnL w="6350" cap="flat" cmpd="sng" algn="ctr">
-                      <a:solidFill>
-                        <a:srgbClr val="CCDDCC"/>
-                      </a:solidFill>
-                      <a:prstDash val="solid"/>
-                      <a:round/>
-                      <a:headEnd type="none" w="med" len="med"/>
-                      <a:tailEnd type="none" w="med" len="med"/>
-                    </a:lnL>
-                    <a:lnR w="6350" cap="flat" cmpd="sng" algn="ctr">
-                      <a:solidFill>
-                        <a:srgbClr val="CCDDCC"/>
-                      </a:solidFill>
-                      <a:prstDash val="solid"/>
-                      <a:round/>
-                      <a:headEnd type="none" w="med" len="med"/>
-                      <a:tailEnd type="none" w="med" len="med"/>
-                    </a:lnR>
-                    <a:lnT w="6350" cap="flat" cmpd="sng" algn="ctr">
-                      <a:solidFill>
-                        <a:srgbClr val="CCDDCC"/>
-                      </a:solidFill>
-                      <a:prstDash val="solid"/>
-                      <a:round/>
-                      <a:headEnd type="none" w="med" len="med"/>
-                      <a:tailEnd type="none" w="med" len="med"/>
-                    </a:lnT>
-                    <a:lnB w="6350" cap="flat" cmpd="sng" algn="ctr">
-                      <a:solidFill>
-                        <a:srgbClr val="CCDDCC"/>
-                      </a:solidFill>
-                      <a:prstDash val="solid"/>
-                      <a:round/>
-                      <a:headEnd type="none" w="med" len="med"/>
-                      <a:tailEnd type="none" w="med" len="med"/>
-                    </a:lnB>
-                    <a:solidFill>
-                      <a:srgbClr val="FFFFFF"/>
-                    </a:solidFill>
-                  </a:tcPr>
-                </a:tc>
-                <a:extLst>
-                  <a:ext uri="{0D108BD9-81ED-4DB2-BD59-A6C34878D82A}">
-                    <a16:rowId xmlns:a16="http://schemas.microsoft.com/office/drawing/2014/main" val="10001"/>
-                  </a:ext>
-                </a:extLst>
-              </a:tr>
-              <a:tr h="393192">
-                <a:tc>
-                  <a:txBody>
-                    <a:bodyPr/>
-                    <a:lstStyle/>
-                    <a:p>
-                      <a:pPr marL="0" indent="0">
-                        <a:buNone/>
-                      </a:pPr>
-                      <a:r>
-                        <a:rPr lang="en-US" sz="1100" dirty="0">
-                          <a:solidFill>
-                            <a:srgbClr val="334155"/>
-                          </a:solidFill>
-                          <a:latin typeface="Calibri" pitchFamily="34" charset="0"/>
-                          <a:ea typeface="Calibri" pitchFamily="34" charset="-122"/>
-                          <a:cs typeface="Calibri" pitchFamily="34" charset="-120"/>
-                        </a:rPr>
-                        <a:t>123</a:t>
-                      </a:r>
-                      <a:endParaRPr lang="en-US" sz="1100" dirty="0">
-                        <a:latin typeface="Calibri" charset="0"/>
-                        <a:ea typeface="Calibri" charset="0"/>
-                        <a:cs typeface="Calibri" charset="0"/>
-                      </a:endParaRPr>
-                    </a:p>
-                  </a:txBody>
-                  <a:tcPr>
-                    <a:lnL w="6350" cap="flat" cmpd="sng" algn="ctr">
-                      <a:solidFill>
-                        <a:srgbClr val="CCDDCC"/>
-                      </a:solidFill>
-                      <a:prstDash val="solid"/>
-                      <a:round/>
-                      <a:headEnd type="none" w="med" len="med"/>
-                      <a:tailEnd type="none" w="med" len="med"/>
-                    </a:lnL>
-                    <a:lnR w="6350" cap="flat" cmpd="sng" algn="ctr">
-                      <a:solidFill>
-                        <a:srgbClr val="CCDDCC"/>
-                      </a:solidFill>
-                      <a:prstDash val="solid"/>
-                      <a:round/>
-                      <a:headEnd type="none" w="med" len="med"/>
-                      <a:tailEnd type="none" w="med" len="med"/>
-                    </a:lnR>
-                    <a:lnT w="6350" cap="flat" cmpd="sng" algn="ctr">
-                      <a:solidFill>
-                        <a:srgbClr val="CCDDCC"/>
-                      </a:solidFill>
-                      <a:prstDash val="solid"/>
-                      <a:round/>
-                      <a:headEnd type="none" w="med" len="med"/>
-                      <a:tailEnd type="none" w="med" len="med"/>
-                    </a:lnT>
-                    <a:lnB w="6350" cap="flat" cmpd="sng" algn="ctr">
-                      <a:solidFill>
-                        <a:srgbClr val="CCDDCC"/>
-                      </a:solidFill>
-                      <a:prstDash val="solid"/>
-                      <a:round/>
-                      <a:headEnd type="none" w="med" len="med"/>
-                      <a:tailEnd type="none" w="med" len="med"/>
-                    </a:lnB>
-                    <a:solidFill>
-                      <a:srgbClr val="FFFFFF"/>
-                    </a:solidFill>
-                  </a:tcPr>
-                </a:tc>
-                <a:tc>
-                  <a:txBody>
-                    <a:bodyPr/>
-                    <a:lstStyle/>
-                    <a:p>
-                      <a:pPr marL="0" indent="0">
-                        <a:buNone/>
-                      </a:pPr>
-                      <a:r>
-                        <a:rPr lang="en-US" sz="1100" dirty="0">
-                          <a:solidFill>
-                            <a:srgbClr val="334155"/>
-                          </a:solidFill>
-                          <a:latin typeface="Calibri" pitchFamily="34" charset="0"/>
-                          <a:ea typeface="Calibri" pitchFamily="34" charset="-122"/>
-                          <a:cs typeface="Calibri" pitchFamily="34" charset="-120"/>
-                        </a:rPr>
-                        <a:t>0,9990</a:t>
-                      </a:r>
-                      <a:endParaRPr lang="en-US" sz="1100" dirty="0">
-                        <a:latin typeface="Calibri" charset="0"/>
-                        <a:ea typeface="Calibri" charset="0"/>
-                        <a:cs typeface="Calibri" charset="0"/>
-                      </a:endParaRPr>
-                    </a:p>
-                  </a:txBody>
-                  <a:tcPr>
-                    <a:lnL w="6350" cap="flat" cmpd="sng" algn="ctr">
-                      <a:solidFill>
-                        <a:srgbClr val="CCDDCC"/>
-                      </a:solidFill>
-                      <a:prstDash val="solid"/>
-                      <a:round/>
-                      <a:headEnd type="none" w="med" len="med"/>
-                      <a:tailEnd type="none" w="med" len="med"/>
-                    </a:lnL>
-                    <a:lnR w="6350" cap="flat" cmpd="sng" algn="ctr">
-                      <a:solidFill>
-                        <a:srgbClr val="CCDDCC"/>
-                      </a:solidFill>
-                      <a:prstDash val="solid"/>
-                      <a:round/>
-                      <a:headEnd type="none" w="med" len="med"/>
-                      <a:tailEnd type="none" w="med" len="med"/>
-                    </a:lnR>
-                    <a:lnT w="6350" cap="flat" cmpd="sng" algn="ctr">
-                      <a:solidFill>
-                        <a:srgbClr val="CCDDCC"/>
-                      </a:solidFill>
-                      <a:prstDash val="solid"/>
-                      <a:round/>
-                      <a:headEnd type="none" w="med" len="med"/>
-                      <a:tailEnd type="none" w="med" len="med"/>
-                    </a:lnT>
-                    <a:lnB w="6350" cap="flat" cmpd="sng" algn="ctr">
-                      <a:solidFill>
-                        <a:srgbClr val="CCDDCC"/>
-                      </a:solidFill>
-                      <a:prstDash val="solid"/>
-                      <a:round/>
-                      <a:headEnd type="none" w="med" len="med"/>
-                      <a:tailEnd type="none" w="med" len="med"/>
-                    </a:lnB>
-                    <a:solidFill>
-                      <a:srgbClr val="FFFFFF"/>
-                    </a:solidFill>
-                  </a:tcPr>
-                </a:tc>
-                <a:tc>
-                  <a:txBody>
-                    <a:bodyPr/>
-                    <a:lstStyle/>
-                    <a:p>
-                      <a:pPr marL="0" indent="0">
-                        <a:buNone/>
-                      </a:pPr>
-                      <a:r>
-                        <a:rPr lang="en-US" sz="1100" dirty="0">
-                          <a:solidFill>
-                            <a:srgbClr val="334155"/>
-                          </a:solidFill>
-                          <a:latin typeface="Calibri" pitchFamily="34" charset="0"/>
-                          <a:ea typeface="Calibri" pitchFamily="34" charset="-122"/>
-                          <a:cs typeface="Calibri" pitchFamily="34" charset="-120"/>
-                        </a:rPr>
-                        <a:t>0,8893</a:t>
-                      </a:r>
-                      <a:endParaRPr lang="en-US" sz="1100" dirty="0">
-                        <a:latin typeface="Calibri" charset="0"/>
-                        <a:ea typeface="Calibri" charset="0"/>
-                        <a:cs typeface="Calibri" charset="0"/>
-                      </a:endParaRPr>
-                    </a:p>
-                  </a:txBody>
-                  <a:tcPr>
-                    <a:lnL w="6350" cap="flat" cmpd="sng" algn="ctr">
-                      <a:solidFill>
-                        <a:srgbClr val="CCDDCC"/>
-                      </a:solidFill>
-                      <a:prstDash val="solid"/>
-                      <a:round/>
-                      <a:headEnd type="none" w="med" len="med"/>
-                      <a:tailEnd type="none" w="med" len="med"/>
-                    </a:lnL>
-                    <a:lnR w="6350" cap="flat" cmpd="sng" algn="ctr">
-                      <a:solidFill>
-                        <a:srgbClr val="CCDDCC"/>
-                      </a:solidFill>
-                      <a:prstDash val="solid"/>
-                      <a:round/>
-                      <a:headEnd type="none" w="med" len="med"/>
-                      <a:tailEnd type="none" w="med" len="med"/>
-                    </a:lnR>
-                    <a:lnT w="6350" cap="flat" cmpd="sng" algn="ctr">
-                      <a:solidFill>
-                        <a:srgbClr val="CCDDCC"/>
-                      </a:solidFill>
-                      <a:prstDash val="solid"/>
-                      <a:round/>
-                      <a:headEnd type="none" w="med" len="med"/>
-                      <a:tailEnd type="none" w="med" len="med"/>
-                    </a:lnT>
-                    <a:lnB w="6350" cap="flat" cmpd="sng" algn="ctr">
-                      <a:solidFill>
-                        <a:srgbClr val="CCDDCC"/>
-                      </a:solidFill>
-                      <a:prstDash val="solid"/>
-                      <a:round/>
-                      <a:headEnd type="none" w="med" len="med"/>
-                      <a:tailEnd type="none" w="med" len="med"/>
-                    </a:lnB>
-                    <a:solidFill>
-                      <a:srgbClr val="FFFFFF"/>
-                    </a:solidFill>
-                  </a:tcPr>
-                </a:tc>
-                <a:tc>
-                  <a:txBody>
-                    <a:bodyPr/>
-                    <a:lstStyle/>
-                    <a:p>
-                      <a:pPr marL="0" indent="0">
-                        <a:buNone/>
-                      </a:pPr>
-                      <a:r>
-                        <a:rPr lang="en-US" sz="1100" dirty="0">
-                          <a:solidFill>
-                            <a:srgbClr val="334155"/>
-                          </a:solidFill>
-                          <a:latin typeface="Calibri" pitchFamily="34" charset="0"/>
-                          <a:ea typeface="Calibri" pitchFamily="34" charset="-122"/>
-                          <a:cs typeface="Calibri" pitchFamily="34" charset="-120"/>
-                        </a:rPr>
-                        <a:t>0,8854</a:t>
-                      </a:r>
-                      <a:endParaRPr lang="en-US" sz="1100" dirty="0">
-                        <a:latin typeface="Calibri" charset="0"/>
-                        <a:ea typeface="Calibri" charset="0"/>
-                        <a:cs typeface="Calibri" charset="0"/>
-                      </a:endParaRPr>
-                    </a:p>
-                  </a:txBody>
-                  <a:tcPr>
-                    <a:lnL w="6350" cap="flat" cmpd="sng" algn="ctr">
-                      <a:solidFill>
-                        <a:srgbClr val="CCDDCC"/>
-                      </a:solidFill>
-                      <a:prstDash val="solid"/>
-                      <a:round/>
-                      <a:headEnd type="none" w="med" len="med"/>
-                      <a:tailEnd type="none" w="med" len="med"/>
-                    </a:lnL>
-                    <a:lnR w="6350" cap="flat" cmpd="sng" algn="ctr">
-                      <a:solidFill>
-                        <a:srgbClr val="CCDDCC"/>
-                      </a:solidFill>
-                      <a:prstDash val="solid"/>
-                      <a:round/>
-                      <a:headEnd type="none" w="med" len="med"/>
-                      <a:tailEnd type="none" w="med" len="med"/>
-                    </a:lnR>
-                    <a:lnT w="6350" cap="flat" cmpd="sng" algn="ctr">
-                      <a:solidFill>
-                        <a:srgbClr val="CCDDCC"/>
-                      </a:solidFill>
-                      <a:prstDash val="solid"/>
-                      <a:round/>
-                      <a:headEnd type="none" w="med" len="med"/>
-                      <a:tailEnd type="none" w="med" len="med"/>
-                    </a:lnT>
-                    <a:lnB w="6350" cap="flat" cmpd="sng" algn="ctr">
-                      <a:solidFill>
-                        <a:srgbClr val="CCDDCC"/>
-                      </a:solidFill>
-                      <a:prstDash val="solid"/>
-                      <a:round/>
-                      <a:headEnd type="none" w="med" len="med"/>
-                      <a:tailEnd type="none" w="med" len="med"/>
-                    </a:lnB>
-                    <a:solidFill>
-                      <a:srgbClr val="FFFFFF"/>
-                    </a:solidFill>
-                  </a:tcPr>
-                </a:tc>
-                <a:extLst>
-                  <a:ext uri="{0D108BD9-81ED-4DB2-BD59-A6C34878D82A}">
-                    <a16:rowId xmlns:a16="http://schemas.microsoft.com/office/drawing/2014/main" val="10002"/>
-                  </a:ext>
-                </a:extLst>
-              </a:tr>
-              <a:tr h="393192">
-                <a:tc>
-                  <a:txBody>
-                    <a:bodyPr/>
-                    <a:lstStyle/>
-                    <a:p>
-                      <a:pPr marL="0" indent="0">
-                        <a:buNone/>
-                      </a:pPr>
-                      <a:r>
-                        <a:rPr lang="en-US" sz="1100" dirty="0">
-                          <a:solidFill>
-                            <a:srgbClr val="334155"/>
-                          </a:solidFill>
-                          <a:latin typeface="Calibri" pitchFamily="34" charset="0"/>
-                          <a:ea typeface="Calibri" pitchFamily="34" charset="-122"/>
-                          <a:cs typeface="Calibri" pitchFamily="34" charset="-120"/>
-                        </a:rPr>
-                        <a:t>7</a:t>
-                      </a:r>
-                      <a:endParaRPr lang="en-US" sz="1100" dirty="0">
-                        <a:latin typeface="Calibri" charset="0"/>
-                        <a:ea typeface="Calibri" charset="0"/>
-                        <a:cs typeface="Calibri" charset="0"/>
-                      </a:endParaRPr>
-                    </a:p>
-                  </a:txBody>
-                  <a:tcPr>
-                    <a:lnL w="6350" cap="flat" cmpd="sng" algn="ctr">
-                      <a:solidFill>
-                        <a:srgbClr val="CCDDCC"/>
-                      </a:solidFill>
-                      <a:prstDash val="solid"/>
-                      <a:round/>
-                      <a:headEnd type="none" w="med" len="med"/>
-                      <a:tailEnd type="none" w="med" len="med"/>
-                    </a:lnL>
-                    <a:lnR w="6350" cap="flat" cmpd="sng" algn="ctr">
-                      <a:solidFill>
-                        <a:srgbClr val="CCDDCC"/>
-                      </a:solidFill>
-                      <a:prstDash val="solid"/>
-                      <a:round/>
-                      <a:headEnd type="none" w="med" len="med"/>
-                      <a:tailEnd type="none" w="med" len="med"/>
-                    </a:lnR>
-                    <a:lnT w="6350" cap="flat" cmpd="sng" algn="ctr">
-                      <a:solidFill>
-                        <a:srgbClr val="CCDDCC"/>
-                      </a:solidFill>
-                      <a:prstDash val="solid"/>
-                      <a:round/>
-                      <a:headEnd type="none" w="med" len="med"/>
-                      <a:tailEnd type="none" w="med" len="med"/>
-                    </a:lnT>
-                    <a:lnB w="6350" cap="flat" cmpd="sng" algn="ctr">
-                      <a:solidFill>
-                        <a:srgbClr val="CCDDCC"/>
-                      </a:solidFill>
-                      <a:prstDash val="solid"/>
-                      <a:round/>
-                      <a:headEnd type="none" w="med" len="med"/>
-                      <a:tailEnd type="none" w="med" len="med"/>
-                    </a:lnB>
-                    <a:solidFill>
-                      <a:srgbClr val="FFFFFF"/>
-                    </a:solidFill>
-                  </a:tcPr>
-                </a:tc>
-                <a:tc>
-                  <a:txBody>
-                    <a:bodyPr/>
-                    <a:lstStyle/>
-                    <a:p>
-                      <a:pPr marL="0" indent="0">
-                        <a:buNone/>
-                      </a:pPr>
-                      <a:r>
-                        <a:rPr lang="en-US" sz="1100" dirty="0">
-                          <a:solidFill>
-                            <a:srgbClr val="334155"/>
-                          </a:solidFill>
-                          <a:latin typeface="Calibri" pitchFamily="34" charset="0"/>
-                          <a:ea typeface="Calibri" pitchFamily="34" charset="-122"/>
-                          <a:cs typeface="Calibri" pitchFamily="34" charset="-120"/>
-                        </a:rPr>
-                        <a:t>0,9990</a:t>
-                      </a:r>
-                      <a:endParaRPr lang="en-US" sz="1100" dirty="0">
-                        <a:latin typeface="Calibri" charset="0"/>
-                        <a:ea typeface="Calibri" charset="0"/>
-                        <a:cs typeface="Calibri" charset="0"/>
-                      </a:endParaRPr>
-                    </a:p>
-                  </a:txBody>
-                  <a:tcPr>
-                    <a:lnL w="6350" cap="flat" cmpd="sng" algn="ctr">
-                      <a:solidFill>
-                        <a:srgbClr val="CCDDCC"/>
-                      </a:solidFill>
-                      <a:prstDash val="solid"/>
-                      <a:round/>
-                      <a:headEnd type="none" w="med" len="med"/>
-                      <a:tailEnd type="none" w="med" len="med"/>
-                    </a:lnL>
-                    <a:lnR w="6350" cap="flat" cmpd="sng" algn="ctr">
-                      <a:solidFill>
-                        <a:srgbClr val="CCDDCC"/>
-                      </a:solidFill>
-                      <a:prstDash val="solid"/>
-                      <a:round/>
-                      <a:headEnd type="none" w="med" len="med"/>
-                      <a:tailEnd type="none" w="med" len="med"/>
-                    </a:lnR>
-                    <a:lnT w="6350" cap="flat" cmpd="sng" algn="ctr">
-                      <a:solidFill>
-                        <a:srgbClr val="CCDDCC"/>
-                      </a:solidFill>
-                      <a:prstDash val="solid"/>
-                      <a:round/>
-                      <a:headEnd type="none" w="med" len="med"/>
-                      <a:tailEnd type="none" w="med" len="med"/>
-                    </a:lnT>
-                    <a:lnB w="6350" cap="flat" cmpd="sng" algn="ctr">
-                      <a:solidFill>
-                        <a:srgbClr val="CCDDCC"/>
-                      </a:solidFill>
-                      <a:prstDash val="solid"/>
-                      <a:round/>
-                      <a:headEnd type="none" w="med" len="med"/>
-                      <a:tailEnd type="none" w="med" len="med"/>
-                    </a:lnB>
-                    <a:solidFill>
-                      <a:srgbClr val="FFFFFF"/>
-                    </a:solidFill>
-                  </a:tcPr>
-                </a:tc>
-                <a:tc>
-                  <a:txBody>
-                    <a:bodyPr/>
-                    <a:lstStyle/>
-                    <a:p>
-                      <a:pPr marL="0" indent="0">
-                        <a:buNone/>
-                      </a:pPr>
-                      <a:r>
-                        <a:rPr lang="en-US" sz="1100" dirty="0">
-                          <a:solidFill>
-                            <a:srgbClr val="334155"/>
-                          </a:solidFill>
-                          <a:latin typeface="Calibri" pitchFamily="34" charset="0"/>
-                          <a:ea typeface="Calibri" pitchFamily="34" charset="-122"/>
-                          <a:cs typeface="Calibri" pitchFamily="34" charset="-120"/>
-                        </a:rPr>
-                        <a:t>0,8893</a:t>
-                      </a:r>
-                      <a:endParaRPr lang="en-US" sz="1100" dirty="0">
-                        <a:latin typeface="Calibri" charset="0"/>
-                        <a:ea typeface="Calibri" charset="0"/>
-                        <a:cs typeface="Calibri" charset="0"/>
-                      </a:endParaRPr>
-                    </a:p>
-                  </a:txBody>
-                  <a:tcPr>
-                    <a:lnL w="6350" cap="flat" cmpd="sng" algn="ctr">
-                      <a:solidFill>
-                        <a:srgbClr val="CCDDCC"/>
-                      </a:solidFill>
-                      <a:prstDash val="solid"/>
-                      <a:round/>
-                      <a:headEnd type="none" w="med" len="med"/>
-                      <a:tailEnd type="none" w="med" len="med"/>
-                    </a:lnL>
-                    <a:lnR w="6350" cap="flat" cmpd="sng" algn="ctr">
-                      <a:solidFill>
-                        <a:srgbClr val="CCDDCC"/>
-                      </a:solidFill>
-                      <a:prstDash val="solid"/>
-                      <a:round/>
-                      <a:headEnd type="none" w="med" len="med"/>
-                      <a:tailEnd type="none" w="med" len="med"/>
-                    </a:lnR>
-                    <a:lnT w="6350" cap="flat" cmpd="sng" algn="ctr">
-                      <a:solidFill>
-                        <a:srgbClr val="CCDDCC"/>
-                      </a:solidFill>
-                      <a:prstDash val="solid"/>
-                      <a:round/>
-                      <a:headEnd type="none" w="med" len="med"/>
-                      <a:tailEnd type="none" w="med" len="med"/>
-                    </a:lnT>
-                    <a:lnB w="6350" cap="flat" cmpd="sng" algn="ctr">
-                      <a:solidFill>
-                        <a:srgbClr val="CCDDCC"/>
-                      </a:solidFill>
-                      <a:prstDash val="solid"/>
-                      <a:round/>
-                      <a:headEnd type="none" w="med" len="med"/>
-                      <a:tailEnd type="none" w="med" len="med"/>
-                    </a:lnB>
-                    <a:solidFill>
-                      <a:srgbClr val="FFFFFF"/>
-                    </a:solidFill>
-                  </a:tcPr>
-                </a:tc>
-                <a:tc>
-                  <a:txBody>
-                    <a:bodyPr/>
-                    <a:lstStyle/>
-                    <a:p>
-                      <a:pPr marL="0" indent="0">
-                        <a:buNone/>
-                      </a:pPr>
-                      <a:r>
-                        <a:rPr lang="en-US" sz="1100" dirty="0">
-                          <a:solidFill>
-                            <a:srgbClr val="334155"/>
-                          </a:solidFill>
-                          <a:latin typeface="Calibri" pitchFamily="34" charset="0"/>
-                          <a:ea typeface="Calibri" pitchFamily="34" charset="-122"/>
-                          <a:cs typeface="Calibri" pitchFamily="34" charset="-120"/>
-                        </a:rPr>
-                        <a:t>0,8696</a:t>
-                      </a:r>
-                      <a:endParaRPr lang="en-US" sz="1100" dirty="0">
-                        <a:latin typeface="Calibri" charset="0"/>
-                        <a:ea typeface="Calibri" charset="0"/>
-                        <a:cs typeface="Calibri" charset="0"/>
-                      </a:endParaRPr>
-                    </a:p>
-                  </a:txBody>
-                  <a:tcPr>
-                    <a:lnL w="6350" cap="flat" cmpd="sng" algn="ctr">
-                      <a:solidFill>
-                        <a:srgbClr val="CCDDCC"/>
-                      </a:solidFill>
-                      <a:prstDash val="solid"/>
-                      <a:round/>
-                      <a:headEnd type="none" w="med" len="med"/>
-                      <a:tailEnd type="none" w="med" len="med"/>
-                    </a:lnL>
-                    <a:lnR w="6350" cap="flat" cmpd="sng" algn="ctr">
-                      <a:solidFill>
-                        <a:srgbClr val="CCDDCC"/>
-                      </a:solidFill>
-                      <a:prstDash val="solid"/>
-                      <a:round/>
-                      <a:headEnd type="none" w="med" len="med"/>
-                      <a:tailEnd type="none" w="med" len="med"/>
-                    </a:lnR>
-                    <a:lnT w="6350" cap="flat" cmpd="sng" algn="ctr">
-                      <a:solidFill>
-                        <a:srgbClr val="CCDDCC"/>
-                      </a:solidFill>
-                      <a:prstDash val="solid"/>
-                      <a:round/>
-                      <a:headEnd type="none" w="med" len="med"/>
-                      <a:tailEnd type="none" w="med" len="med"/>
-                    </a:lnT>
-                    <a:lnB w="6350" cap="flat" cmpd="sng" algn="ctr">
-                      <a:solidFill>
-                        <a:srgbClr val="CCDDCC"/>
-                      </a:solidFill>
-                      <a:prstDash val="solid"/>
-                      <a:round/>
-                      <a:headEnd type="none" w="med" len="med"/>
-                      <a:tailEnd type="none" w="med" len="med"/>
-                    </a:lnB>
-                    <a:solidFill>
-                      <a:srgbClr val="FFFFFF"/>
-                    </a:solidFill>
-                  </a:tcPr>
-                </a:tc>
-                <a:extLst>
-                  <a:ext uri="{0D108BD9-81ED-4DB2-BD59-A6C34878D82A}">
-                    <a16:rowId xmlns:a16="http://schemas.microsoft.com/office/drawing/2014/main" val="10003"/>
-                  </a:ext>
-                </a:extLst>
-              </a:tr>
-              <a:tr h="393192">
-                <a:tc>
-                  <a:txBody>
-                    <a:bodyPr/>
-                    <a:lstStyle/>
-                    <a:p>
-                      <a:pPr marL="0" indent="0">
-                        <a:buNone/>
-                      </a:pPr>
-                      <a:r>
-                        <a:rPr lang="en-US" sz="1100" dirty="0">
-                          <a:solidFill>
-                            <a:srgbClr val="334155"/>
-                          </a:solidFill>
-                          <a:latin typeface="Calibri" pitchFamily="34" charset="0"/>
-                          <a:ea typeface="Calibri" pitchFamily="34" charset="-122"/>
-                          <a:cs typeface="Calibri" pitchFamily="34" charset="-120"/>
-                        </a:rPr>
-                        <a:t>99</a:t>
-                      </a:r>
-                      <a:endParaRPr lang="en-US" sz="1100" dirty="0">
-                        <a:latin typeface="Calibri" charset="0"/>
-                        <a:ea typeface="Calibri" charset="0"/>
-                        <a:cs typeface="Calibri" charset="0"/>
-                      </a:endParaRPr>
-                    </a:p>
-                  </a:txBody>
-                  <a:tcPr>
-                    <a:lnL w="6350" cap="flat" cmpd="sng" algn="ctr">
-                      <a:solidFill>
-                        <a:srgbClr val="CCDDCC"/>
-                      </a:solidFill>
-                      <a:prstDash val="solid"/>
-                      <a:round/>
-                      <a:headEnd type="none" w="med" len="med"/>
-                      <a:tailEnd type="none" w="med" len="med"/>
-                    </a:lnL>
-                    <a:lnR w="6350" cap="flat" cmpd="sng" algn="ctr">
-                      <a:solidFill>
-                        <a:srgbClr val="CCDDCC"/>
-                      </a:solidFill>
-                      <a:prstDash val="solid"/>
-                      <a:round/>
-                      <a:headEnd type="none" w="med" len="med"/>
-                      <a:tailEnd type="none" w="med" len="med"/>
-                    </a:lnR>
-                    <a:lnT w="6350" cap="flat" cmpd="sng" algn="ctr">
-                      <a:solidFill>
-                        <a:srgbClr val="CCDDCC"/>
-                      </a:solidFill>
-                      <a:prstDash val="solid"/>
-                      <a:round/>
-                      <a:headEnd type="none" w="med" len="med"/>
-                      <a:tailEnd type="none" w="med" len="med"/>
-                    </a:lnT>
-                    <a:lnB w="6350" cap="flat" cmpd="sng" algn="ctr">
-                      <a:solidFill>
-                        <a:srgbClr val="CCDDCC"/>
-                      </a:solidFill>
-                      <a:prstDash val="solid"/>
-                      <a:round/>
-                      <a:headEnd type="none" w="med" len="med"/>
-                      <a:tailEnd type="none" w="med" len="med"/>
-                    </a:lnB>
-                    <a:solidFill>
-                      <a:srgbClr val="FFFFFF"/>
-                    </a:solidFill>
-                  </a:tcPr>
-                </a:tc>
-                <a:tc>
-                  <a:txBody>
-                    <a:bodyPr/>
-                    <a:lstStyle/>
-                    <a:p>
-                      <a:pPr marL="0" indent="0">
-                        <a:buNone/>
-                      </a:pPr>
-                      <a:r>
-                        <a:rPr lang="en-US" sz="1100" dirty="0">
-                          <a:solidFill>
-                            <a:srgbClr val="334155"/>
-                          </a:solidFill>
-                          <a:latin typeface="Calibri" pitchFamily="34" charset="0"/>
-                          <a:ea typeface="Calibri" pitchFamily="34" charset="-122"/>
-                          <a:cs typeface="Calibri" pitchFamily="34" charset="-120"/>
-                        </a:rPr>
-                        <a:t>0,9990</a:t>
-                      </a:r>
-                      <a:endParaRPr lang="en-US" sz="1100" dirty="0">
-                        <a:latin typeface="Calibri" charset="0"/>
-                        <a:ea typeface="Calibri" charset="0"/>
-                        <a:cs typeface="Calibri" charset="0"/>
-                      </a:endParaRPr>
-                    </a:p>
-                  </a:txBody>
-                  <a:tcPr>
-                    <a:lnL w="6350" cap="flat" cmpd="sng" algn="ctr">
-                      <a:solidFill>
-                        <a:srgbClr val="CCDDCC"/>
-                      </a:solidFill>
-                      <a:prstDash val="solid"/>
-                      <a:round/>
-                      <a:headEnd type="none" w="med" len="med"/>
-                      <a:tailEnd type="none" w="med" len="med"/>
-                    </a:lnL>
-                    <a:lnR w="6350" cap="flat" cmpd="sng" algn="ctr">
-                      <a:solidFill>
-                        <a:srgbClr val="CCDDCC"/>
-                      </a:solidFill>
-                      <a:prstDash val="solid"/>
-                      <a:round/>
-                      <a:headEnd type="none" w="med" len="med"/>
-                      <a:tailEnd type="none" w="med" len="med"/>
-                    </a:lnR>
-                    <a:lnT w="6350" cap="flat" cmpd="sng" algn="ctr">
-                      <a:solidFill>
-                        <a:srgbClr val="CCDDCC"/>
-                      </a:solidFill>
-                      <a:prstDash val="solid"/>
-                      <a:round/>
-                      <a:headEnd type="none" w="med" len="med"/>
-                      <a:tailEnd type="none" w="med" len="med"/>
-                    </a:lnT>
-                    <a:lnB w="6350" cap="flat" cmpd="sng" algn="ctr">
-                      <a:solidFill>
-                        <a:srgbClr val="CCDDCC"/>
-                      </a:solidFill>
-                      <a:prstDash val="solid"/>
-                      <a:round/>
-                      <a:headEnd type="none" w="med" len="med"/>
-                      <a:tailEnd type="none" w="med" len="med"/>
-                    </a:lnB>
-                    <a:solidFill>
-                      <a:srgbClr val="FFFFFF"/>
-                    </a:solidFill>
-                  </a:tcPr>
-                </a:tc>
-                <a:tc>
-                  <a:txBody>
-                    <a:bodyPr/>
-                    <a:lstStyle/>
-                    <a:p>
-                      <a:pPr marL="0" indent="0">
-                        <a:buNone/>
-                      </a:pPr>
-                      <a:r>
-                        <a:rPr lang="en-US" sz="1100" dirty="0">
-                          <a:solidFill>
-                            <a:srgbClr val="334155"/>
-                          </a:solidFill>
-                          <a:latin typeface="Calibri" pitchFamily="34" charset="0"/>
-                          <a:ea typeface="Calibri" pitchFamily="34" charset="-122"/>
-                          <a:cs typeface="Calibri" pitchFamily="34" charset="-120"/>
-                        </a:rPr>
-                        <a:t>0,8933</a:t>
-                      </a:r>
-                      <a:endParaRPr lang="en-US" sz="1100" dirty="0">
-                        <a:latin typeface="Calibri" charset="0"/>
-                        <a:ea typeface="Calibri" charset="0"/>
-                        <a:cs typeface="Calibri" charset="0"/>
-                      </a:endParaRPr>
-                    </a:p>
-                  </a:txBody>
-                  <a:tcPr>
-                    <a:lnL w="6350" cap="flat" cmpd="sng" algn="ctr">
-                      <a:solidFill>
-                        <a:srgbClr val="CCDDCC"/>
-                      </a:solidFill>
-                      <a:prstDash val="solid"/>
-                      <a:round/>
-                      <a:headEnd type="none" w="med" len="med"/>
-                      <a:tailEnd type="none" w="med" len="med"/>
-                    </a:lnL>
-                    <a:lnR w="6350" cap="flat" cmpd="sng" algn="ctr">
-                      <a:solidFill>
-                        <a:srgbClr val="CCDDCC"/>
-                      </a:solidFill>
-                      <a:prstDash val="solid"/>
-                      <a:round/>
-                      <a:headEnd type="none" w="med" len="med"/>
-                      <a:tailEnd type="none" w="med" len="med"/>
-                    </a:lnR>
-                    <a:lnT w="6350" cap="flat" cmpd="sng" algn="ctr">
-                      <a:solidFill>
-                        <a:srgbClr val="CCDDCC"/>
-                      </a:solidFill>
-                      <a:prstDash val="solid"/>
-                      <a:round/>
-                      <a:headEnd type="none" w="med" len="med"/>
-                      <a:tailEnd type="none" w="med" len="med"/>
-                    </a:lnT>
-                    <a:lnB w="6350" cap="flat" cmpd="sng" algn="ctr">
-                      <a:solidFill>
-                        <a:srgbClr val="CCDDCC"/>
-                      </a:solidFill>
-                      <a:prstDash val="solid"/>
-                      <a:round/>
-                      <a:headEnd type="none" w="med" len="med"/>
-                      <a:tailEnd type="none" w="med" len="med"/>
-                    </a:lnB>
-                    <a:solidFill>
-                      <a:srgbClr val="FFFFFF"/>
-                    </a:solidFill>
-                  </a:tcPr>
-                </a:tc>
-                <a:tc>
-                  <a:txBody>
-                    <a:bodyPr/>
-                    <a:lstStyle/>
-                    <a:p>
-                      <a:pPr marL="0" indent="0">
-                        <a:buNone/>
-                      </a:pPr>
-                      <a:r>
-                        <a:rPr lang="en-US" sz="1100" dirty="0">
-                          <a:solidFill>
-                            <a:srgbClr val="334155"/>
-                          </a:solidFill>
-                          <a:latin typeface="Calibri" pitchFamily="34" charset="0"/>
-                          <a:ea typeface="Calibri" pitchFamily="34" charset="-122"/>
-                          <a:cs typeface="Calibri" pitchFamily="34" charset="-120"/>
-                        </a:rPr>
-                        <a:t>0,8972</a:t>
+                        <a:t>0,8537</a:t>
                       </a:r>
                       <a:endParaRPr lang="en-US" sz="1100" dirty="0">
                         <a:latin typeface="Calibri" charset="0"/>
@@ -11771,7 +9975,7 @@
                           <a:ea typeface="Calibri" pitchFamily="34" charset="-122"/>
                           <a:cs typeface="Calibri" pitchFamily="34" charset="-120"/>
                         </a:rPr>
-                        <a:t>0,8923</a:t>
+                        <a:t>0,90265</a:t>
                       </a:r>
                       <a:endParaRPr lang="en-US" sz="1100" dirty="0">
                         <a:latin typeface="Calibri" charset="0"/>
@@ -11839,7 +10043,7 @@
                           <a:ea typeface="Calibri" pitchFamily="34" charset="-122"/>
                           <a:cs typeface="Calibri" pitchFamily="34" charset="-120"/>
                         </a:rPr>
-                        <a:t>0,8883</a:t>
+                        <a:t>0,8754</a:t>
                       </a:r>
                       <a:endParaRPr lang="en-US" sz="1100" dirty="0">
                         <a:latin typeface="Calibri" charset="0"/>
@@ -11927,6 +10131,53 @@
           </a:p>
         </p:txBody>
       </p:sp>
+      <p:pic>
+        <p:nvPicPr>
+          <p:cNvPr id="1026" name="Picture 2">
+            <a:extLst>
+              <a:ext uri="{FF2B5EF4-FFF2-40B4-BE49-F238E27FC236}">
+                <a16:creationId xmlns:a16="http://schemas.microsoft.com/office/drawing/2014/main" id="{2354EB3B-D41C-0275-6902-169000259F8D}"/>
+              </a:ext>
+            </a:extLst>
+          </p:cNvPr>
+          <p:cNvPicPr>
+            <a:picLocks noChangeAspect="1" noChangeArrowheads="1"/>
+          </p:cNvPicPr>
+          <p:nvPr/>
+        </p:nvPicPr>
+        <p:blipFill>
+          <a:blip r:embed="rId3">
+            <a:extLst>
+              <a:ext uri="{28A0092B-C50C-407E-A947-70E740481C1C}">
+                <a14:useLocalDpi xmlns:a14="http://schemas.microsoft.com/office/drawing/2010/main" val="0"/>
+              </a:ext>
+            </a:extLst>
+          </a:blip>
+          <a:srcRect/>
+          <a:stretch>
+            <a:fillRect/>
+          </a:stretch>
+        </p:blipFill>
+        <p:spPr bwMode="auto">
+          <a:xfrm>
+            <a:off x="4738116" y="2212657"/>
+            <a:ext cx="4114800" cy="2359152"/>
+          </a:xfrm>
+          <a:prstGeom prst="rect">
+            <a:avLst/>
+          </a:prstGeom>
+          <a:noFill/>
+          <a:extLst>
+            <a:ext uri="{909E8E84-426E-40DD-AFC4-6F175D3DCCD1}">
+              <a14:hiddenFill xmlns:a14="http://schemas.microsoft.com/office/drawing/2010/main">
+                <a:solidFill>
+                  <a:srgbClr val="FFFFFF"/>
+                </a:solidFill>
+              </a14:hiddenFill>
+            </a:ext>
+          </a:extLst>
+        </p:spPr>
+      </p:pic>
     </p:spTree>
   </p:cSld>
   <p:clrMapOvr>

</xml_diff>